<commit_message>
Issue #190 - Improved temporal analysis
Improved the explanation for the temporal analysis for the USEI09 code
</commit_message>
<xml_diff>
--- a/scrum/sprint1/LAPR3-Sprint1-Report_G091.pptx
+++ b/scrum/sprint1/LAPR3-Sprint1-Report_G091.pptx
@@ -149,9 +149,37 @@
 <file path=ppt/revisionInfo.xml><?xml version="1.0" encoding="utf-8"?>
 <p1510:revInfo xmlns:a="http://schemas.openxmlformats.org/drawingml/2006/main" xmlns:r="http://schemas.openxmlformats.org/officeDocument/2006/relationships" xmlns:p1510="http://schemas.microsoft.com/office/powerpoint/2015/10/main">
   <p1510:revLst>
-    <p1510:client id="{99C756E8-1A4A-4A82-B6C0-04ED6CB128C2}" v="84" dt="2024-10-22T15:32:15.800"/>
+    <p1510:client id="{1BAA328A-AB61-461B-A1A9-D9AE1991A846}" v="1" dt="2025-11-23T23:08:09.414"/>
   </p1510:revLst>
 </p1510:revInfo>
+</file>
+
+<file path=ppt/changesInfos/changesInfo1.xml><?xml version="1.0" encoding="utf-8"?>
+<pc:chgInfo xmlns:a="http://schemas.openxmlformats.org/drawingml/2006/main" xmlns:r="http://schemas.openxmlformats.org/officeDocument/2006/relationships" xmlns:ac="http://schemas.microsoft.com/office/drawing/2013/main/command" xmlns:pc="http://schemas.microsoft.com/office/powerpoint/2013/main/command">
+  <pc:docChgLst>
+    <pc:chgData name="Diogo Silva" userId="2a52c7efdf56790c" providerId="LiveId" clId="{C5AB9241-1DF5-4D1A-A14E-CC9DD3B62124}"/>
+    <pc:docChg chg="addSld delSld modSld">
+      <pc:chgData name="Diogo Silva" userId="2a52c7efdf56790c" providerId="LiveId" clId="{C5AB9241-1DF5-4D1A-A14E-CC9DD3B62124}" dt="2025-11-24T12:40:19.051" v="7" actId="27918"/>
+      <pc:docMkLst>
+        <pc:docMk/>
+      </pc:docMkLst>
+      <pc:sldChg chg="mod">
+        <pc:chgData name="Diogo Silva" userId="2a52c7efdf56790c" providerId="LiveId" clId="{C5AB9241-1DF5-4D1A-A14E-CC9DD3B62124}" dt="2025-11-24T12:40:19.051" v="7" actId="27918"/>
+        <pc:sldMkLst>
+          <pc:docMk/>
+          <pc:sldMk cId="806292261" sldId="407"/>
+        </pc:sldMkLst>
+      </pc:sldChg>
+      <pc:sldChg chg="add del">
+        <pc:chgData name="Diogo Silva" userId="2a52c7efdf56790c" providerId="LiveId" clId="{C5AB9241-1DF5-4D1A-A14E-CC9DD3B62124}" dt="2025-11-23T23:08:11.739" v="1" actId="47"/>
+        <pc:sldMkLst>
+          <pc:docMk/>
+          <pc:sldMk cId="3621787753" sldId="416"/>
+        </pc:sldMkLst>
+      </pc:sldChg>
+    </pc:docChg>
+  </pc:docChgLst>
+</pc:chgInfo>
 </file>
 
 <file path=ppt/charts/chart1.xml><?xml version="1.0" encoding="utf-8"?>
@@ -2093,7 +2121,7 @@
             <a:fld id="{5D8AA918-AAAF-A948-AD9D-7282A6CA6554}" type="datetimeFigureOut">
               <a:rPr lang="en-US" smtClean="0"/>
               <a:pPr/>
-              <a:t>10/26/2025</a:t>
+              <a:t>11/24/2025</a:t>
             </a:fld>
             <a:endParaRPr lang="pt-PT"/>
           </a:p>
@@ -2909,7 +2937,7 @@
             <a:fld id="{44B11A7A-C2E1-40A3-A304-BADFC0305F97}" type="datetimeFigureOut">
               <a:rPr lang="pt-PT" smtClean="0"/>
               <a:pPr/>
-              <a:t>26/10/2025</a:t>
+              <a:t>24/11/2025</a:t>
             </a:fld>
             <a:endParaRPr lang="pt-PT"/>
           </a:p>
@@ -3096,7 +3124,7 @@
             <a:fld id="{44B11A7A-C2E1-40A3-A304-BADFC0305F97}" type="datetimeFigureOut">
               <a:rPr lang="pt-PT" smtClean="0"/>
               <a:pPr/>
-              <a:t>26/10/2025</a:t>
+              <a:t>24/11/2025</a:t>
             </a:fld>
             <a:endParaRPr lang="pt-PT"/>
           </a:p>
@@ -3573,7 +3601,7 @@
             <a:fld id="{44B11A7A-C2E1-40A3-A304-BADFC0305F97}" type="datetimeFigureOut">
               <a:rPr lang="pt-PT" smtClean="0"/>
               <a:pPr/>
-              <a:t>26/10/2025</a:t>
+              <a:t>24/11/2025</a:t>
             </a:fld>
             <a:endParaRPr lang="pt-PT"/>
           </a:p>
@@ -3755,7 +3783,7 @@
             <a:fld id="{44B11A7A-C2E1-40A3-A304-BADFC0305F97}" type="datetimeFigureOut">
               <a:rPr lang="pt-PT" smtClean="0"/>
               <a:pPr/>
-              <a:t>26/10/2025</a:t>
+              <a:t>24/11/2025</a:t>
             </a:fld>
             <a:endParaRPr lang="pt-PT"/>
           </a:p>
@@ -11257,7 +11285,13 @@
                   <p:embed/>
                   <p:pic>
                     <p:nvPicPr>
-                      <p:cNvPr id="0" name=""/>
+                      <p:cNvPr id="4" name="Objeto 3">
+                        <a:extLst>
+                          <a:ext uri="{FF2B5EF4-FFF2-40B4-BE49-F238E27FC236}">
+                            <a16:creationId xmlns:a16="http://schemas.microsoft.com/office/drawing/2014/main" id="{74F754A2-C80B-DE8A-3D46-46E6F686995D}"/>
+                          </a:ext>
+                        </a:extLst>
+                      </p:cNvPr>
                       <p:cNvPicPr/>
                       <p:nvPr/>
                     </p:nvPicPr>
@@ -22129,7 +22163,7 @@
           <p:nvPr>
             <p:extLst>
               <p:ext uri="{D42A27DB-BD31-4B8C-83A1-F6EECF244321}">
-                <p14:modId xmlns:p14="http://schemas.microsoft.com/office/powerpoint/2010/main" val="3913645076"/>
+                <p14:modId xmlns:p14="http://schemas.microsoft.com/office/powerpoint/2010/main" val="2960371745"/>
               </p:ext>
             </p:extLst>
           </p:nvPr>
@@ -28555,7 +28589,13 @@
                   <p:embed/>
                   <p:pic>
                     <p:nvPicPr>
-                      <p:cNvPr id="0" name=""/>
+                      <p:cNvPr id="9" name="Objeto 8">
+                        <a:extLst>
+                          <a:ext uri="{FF2B5EF4-FFF2-40B4-BE49-F238E27FC236}">
+                            <a16:creationId xmlns:a16="http://schemas.microsoft.com/office/drawing/2014/main" id="{7CA8DDA6-155B-FB4F-D0AE-13FBF355D5F8}"/>
+                          </a:ext>
+                        </a:extLst>
+                      </p:cNvPr>
                       <p:cNvPicPr/>
                       <p:nvPr/>
                     </p:nvPicPr>

</xml_diff>